<commit_message>
feat: real SlideGNN onnx/safetensors models, true raw template layout rendering, and rich visual sample deck
</commit_message>
<xml_diff>
--- a/backend/samples/sample_12slide_archetypes.pptx
+++ b/backend/samples/sample_12slide_archetypes.pptx
@@ -2033,6 +2033,49 @@
               <a:t>‹#›</a:t>
             </a:fld>
             <a:endParaRPr lang="en-US"/>
+          </a:p>
+        </p:txBody>
+      </p:sp>
+      <p:sp>
+        <p:nvSpPr>
+          <p:cNvPr id="2" name="Rectangle 1"/>
+          <p:cNvSpPr/>
+          <p:nvPr/>
+        </p:nvSpPr>
+        <p:spPr>
+          <a:xfrm>
+            <a:off x="0" y="0"/>
+            <a:ext cx="3291840" cy="6858000"/>
+          </a:xfrm>
+          <a:prstGeom prst="rect">
+            <a:avLst/>
+          </a:prstGeom>
+          <a:solidFill>
+            <a:srgbClr val="F6F3ED"/>
+          </a:solidFill>
+          <a:ln>
+            <a:noFill/>
+          </a:ln>
+        </p:spPr>
+        <p:style>
+          <a:lnRef idx="1">
+            <a:schemeClr val="accent1"/>
+          </a:lnRef>
+          <a:fillRef idx="3">
+            <a:schemeClr val="accent1"/>
+          </a:fillRef>
+          <a:effectRef idx="2">
+            <a:schemeClr val="accent1"/>
+          </a:effectRef>
+          <a:fontRef idx="minor">
+            <a:schemeClr val="lt1"/>
+          </a:fontRef>
+        </p:style>
+        <p:txBody>
+          <a:bodyPr rtlCol="0" anchor="ctr"/>
+          <a:lstStyle/>
+          <a:p>
+            <a:pPr algn="ctr"/>
           </a:p>
         </p:txBody>
       </p:sp>
@@ -3101,14 +3144,57 @@
       <p:grpSpPr/>
       <p:sp>
         <p:nvSpPr>
-          <p:cNvPr id="2" name="TextBox 1"/>
+          <p:cNvPr id="2" name="Rectangle 1"/>
+          <p:cNvSpPr/>
+          <p:nvPr/>
+        </p:nvSpPr>
+        <p:spPr>
+          <a:xfrm>
+            <a:off x="731520" y="1645920"/>
+            <a:ext cx="10698480" cy="73152"/>
+          </a:xfrm>
+          <a:prstGeom prst="rect">
+            <a:avLst/>
+          </a:prstGeom>
+          <a:solidFill>
+            <a:srgbClr val="FFB81C"/>
+          </a:solidFill>
+          <a:ln>
+            <a:noFill/>
+          </a:ln>
+        </p:spPr>
+        <p:style>
+          <a:lnRef idx="1">
+            <a:schemeClr val="accent1"/>
+          </a:lnRef>
+          <a:fillRef idx="3">
+            <a:schemeClr val="accent1"/>
+          </a:fillRef>
+          <a:effectRef idx="2">
+            <a:schemeClr val="accent1"/>
+          </a:effectRef>
+          <a:fontRef idx="minor">
+            <a:schemeClr val="lt1"/>
+          </a:fontRef>
+        </p:style>
+        <p:txBody>
+          <a:bodyPr rtlCol="0" anchor="ctr"/>
+          <a:lstStyle/>
+          <a:p>
+            <a:pPr algn="ctr"/>
+          </a:p>
+        </p:txBody>
+      </p:sp>
+      <p:sp>
+        <p:nvSpPr>
+          <p:cNvPr id="3" name="TextBox 2"/>
           <p:cNvSpPr txBox="1"/>
           <p:nvPr/>
         </p:nvSpPr>
         <p:spPr>
           <a:xfrm>
-            <a:off x="914400" y="1828800"/>
-            <a:ext cx="9144000" cy="1371600"/>
+            <a:off x="731520" y="2103120"/>
+            <a:ext cx="9601200" cy="1463040"/>
           </a:xfrm>
           <a:prstGeom prst="rect">
             <a:avLst/>
@@ -3122,7 +3208,12 @@
           <a:lstStyle/>
           <a:p>
             <a:pPr>
-              <a:defRPr sz="3600" b="1"/>
+              <a:defRPr sz="3600" b="0">
+                <a:solidFill>
+                  <a:srgbClr val="18181B"/>
+                </a:solidFill>
+                <a:latin typeface="Times New Roman"/>
+              </a:defRPr>
             </a:pPr>
             <a:r>
               <a:t>Strategic Corporate Overview</a:t>
@@ -3132,14 +3223,14 @@
       </p:sp>
       <p:sp>
         <p:nvSpPr>
-          <p:cNvPr id="3" name="TextBox 2"/>
+          <p:cNvPr id="4" name="TextBox 3"/>
           <p:cNvSpPr txBox="1"/>
           <p:nvPr/>
         </p:nvSpPr>
         <p:spPr>
           <a:xfrm>
-            <a:off x="914400" y="3474720"/>
-            <a:ext cx="9144000" cy="731520"/>
+            <a:off x="731520" y="3840480"/>
+            <a:ext cx="7772400" cy="731520"/>
           </a:xfrm>
           <a:prstGeom prst="rect">
             <a:avLst/>
@@ -3152,8 +3243,16 @@
           </a:bodyPr>
           <a:lstStyle/>
           <a:p>
-            <a:r>
-              <a:t>Prepared by Leadership Team</a:t>
+            <a:pPr>
+              <a:defRPr sz="1600">
+                <a:solidFill>
+                  <a:srgbClr val="64748B"/>
+                </a:solidFill>
+                <a:latin typeface="Calibri"/>
+              </a:defRPr>
+            </a:pPr>
+            <a:r>
+              <a:t>Prepared for Executive Leadership &amp; Board of Directors</a:t>
             </a:r>
           </a:p>
         </p:txBody>
@@ -3184,7 +3283,7 @@
         </p:nvSpPr>
         <p:spPr>
           <a:xfrm>
-            <a:off x="731520" y="457200"/>
+            <a:off x="731520" y="548640"/>
             <a:ext cx="7315200" cy="731520"/>
           </a:xfrm>
           <a:prstGeom prst="rect">
@@ -3198,6 +3297,9 @@
           </a:bodyPr>
           <a:lstStyle/>
           <a:p>
+            <a:pPr>
+              <a:defRPr sz="2800"/>
+            </a:pPr>
             <a:r>
               <a:t>Global Infrastructure &amp; Scale</a:t>
             </a:r>
@@ -3213,7 +3315,7 @@
         <p:spPr>
           <a:xfrm>
             <a:off x="731520" y="1828800"/>
-            <a:ext cx="5120640" cy="3657600"/>
+            <a:ext cx="5029200" cy="3840480"/>
           </a:xfrm>
           <a:prstGeom prst="rect">
             <a:avLst/>
@@ -3226,8 +3328,19 @@
           </a:bodyPr>
           <a:lstStyle/>
           <a:p>
-            <a:r>
-              <a:t>Zone 1 Regional Datacenter Architecture</a:t>
+            <a:pPr>
+              <a:defRPr sz="1500" b="1"/>
+            </a:pPr>
+            <a:r>
+              <a:t>North America &amp; EMEA Region</a:t>
+            </a:r>
+          </a:p>
+          <a:p>
+            <a:pPr>
+              <a:defRPr sz="1150"/>
+            </a:pPr>
+            <a:r>
+              <a:t>Multi-region edge deployment with sub-10ms response times and automated load balancing.</a:t>
             </a:r>
           </a:p>
         </p:txBody>
@@ -3240,8 +3353,8 @@
         </p:nvSpPr>
         <p:spPr>
           <a:xfrm>
-            <a:off x="6217920" y="1828800"/>
-            <a:ext cx="5120640" cy="3657600"/>
+            <a:off x="6172200" y="1828800"/>
+            <a:ext cx="5029200" cy="3840480"/>
           </a:xfrm>
           <a:prstGeom prst="rect">
             <a:avLst/>
@@ -3254,8 +3367,91 @@
           </a:bodyPr>
           <a:lstStyle/>
           <a:p>
-            <a:r>
-              <a:t>Zone 2 Regional Datacenter Architecture</a:t>
+            <a:pPr>
+              <a:defRPr sz="1500" b="1"/>
+            </a:pPr>
+            <a:r>
+              <a:t>Asia-Pacific &amp; LATAM Region</a:t>
+            </a:r>
+          </a:p>
+          <a:p>
+            <a:pPr>
+              <a:defRPr sz="1150"/>
+            </a:pPr>
+            <a:r>
+              <a:t>Strict localized compliance, multi-lingual font fallback resolution, and isolated tenant storage.</a:t>
+            </a:r>
+          </a:p>
+        </p:txBody>
+      </p:sp>
+      <p:sp>
+        <p:nvSpPr>
+          <p:cNvPr id="5" name="TextBox 4"/>
+          <p:cNvSpPr txBox="1"/>
+          <p:nvPr/>
+        </p:nvSpPr>
+        <p:spPr>
+          <a:xfrm>
+            <a:off x="731520" y="6400800"/>
+            <a:ext cx="4114800" cy="320040"/>
+          </a:xfrm>
+          <a:prstGeom prst="rect">
+            <a:avLst/>
+          </a:prstGeom>
+          <a:noFill/>
+        </p:spPr>
+        <p:txBody>
+          <a:bodyPr wrap="none">
+            <a:spAutoFit/>
+          </a:bodyPr>
+          <a:lstStyle/>
+          <a:p>
+            <a:pPr>
+              <a:defRPr sz="850">
+                <a:solidFill>
+                  <a:srgbClr val="8C96A0"/>
+                </a:solidFill>
+                <a:latin typeface="Calibri"/>
+              </a:defRPr>
+            </a:pPr>
+            <a:r>
+              <a:t>PRESENTATION TITLE</a:t>
+            </a:r>
+          </a:p>
+        </p:txBody>
+      </p:sp>
+      <p:sp>
+        <p:nvSpPr>
+          <p:cNvPr id="6" name="TextBox 5"/>
+          <p:cNvSpPr txBox="1"/>
+          <p:nvPr/>
+        </p:nvSpPr>
+        <p:spPr>
+          <a:xfrm>
+            <a:off x="10972800" y="6400800"/>
+            <a:ext cx="548640" cy="320040"/>
+          </a:xfrm>
+          <a:prstGeom prst="rect">
+            <a:avLst/>
+          </a:prstGeom>
+          <a:noFill/>
+        </p:spPr>
+        <p:txBody>
+          <a:bodyPr wrap="none">
+            <a:spAutoFit/>
+          </a:bodyPr>
+          <a:lstStyle/>
+          <a:p>
+            <a:pPr>
+              <a:defRPr sz="850">
+                <a:solidFill>
+                  <a:srgbClr val="8C96A0"/>
+                </a:solidFill>
+                <a:latin typeface="Calibri"/>
+              </a:defRPr>
+            </a:pPr>
+            <a:r>
+              <a:t>10</a:t>
             </a:r>
           </a:p>
         </p:txBody>
@@ -3286,8 +3482,8 @@
         </p:nvSpPr>
         <p:spPr>
           <a:xfrm>
-            <a:off x="731520" y="457200"/>
-            <a:ext cx="6400800" cy="731520"/>
+            <a:off x="731520" y="548640"/>
+            <a:ext cx="7315200" cy="731520"/>
           </a:xfrm>
           <a:prstGeom prst="rect">
             <a:avLst/>
@@ -3300,99 +3496,18 @@
           </a:bodyPr>
           <a:lstStyle/>
           <a:p>
-            <a:r>
-              <a:t>Risk Governance Framework</a:t>
-            </a:r>
-          </a:p>
-        </p:txBody>
-      </p:sp>
-      <p:sp>
-        <p:nvSpPr>
-          <p:cNvPr id="3" name="TextBox 2"/>
-          <p:cNvSpPr txBox="1"/>
-          <p:nvPr/>
-        </p:nvSpPr>
-        <p:spPr>
-          <a:xfrm>
-            <a:off x="731520" y="1463040"/>
-            <a:ext cx="5029200" cy="1005840"/>
-          </a:xfrm>
-          <a:prstGeom prst="rect">
-            <a:avLst/>
-          </a:prstGeom>
-          <a:noFill/>
-        </p:spPr>
-        <p:txBody>
-          <a:bodyPr wrap="none">
-            <a:spAutoFit/>
-          </a:bodyPr>
-          <a:lstStyle/>
-          <a:p>
-            <a:r>
-              <a:t>Control Level 1: Automated CI/CD Auditing</a:t>
-            </a:r>
-          </a:p>
-        </p:txBody>
-      </p:sp>
-      <p:sp>
-        <p:nvSpPr>
-          <p:cNvPr id="4" name="TextBox 3"/>
-          <p:cNvSpPr txBox="1"/>
-          <p:nvPr/>
-        </p:nvSpPr>
-        <p:spPr>
-          <a:xfrm>
-            <a:off x="731520" y="2834640"/>
-            <a:ext cx="5029200" cy="1005840"/>
-          </a:xfrm>
-          <a:prstGeom prst="rect">
-            <a:avLst/>
-          </a:prstGeom>
-          <a:noFill/>
-        </p:spPr>
-        <p:txBody>
-          <a:bodyPr wrap="none">
-            <a:spAutoFit/>
-          </a:bodyPr>
-          <a:lstStyle/>
-          <a:p>
-            <a:r>
-              <a:t>Control Level 2: Automated CI/CD Auditing</a:t>
-            </a:r>
-          </a:p>
-        </p:txBody>
-      </p:sp>
-      <p:sp>
-        <p:nvSpPr>
-          <p:cNvPr id="5" name="TextBox 4"/>
-          <p:cNvSpPr txBox="1"/>
-          <p:nvPr/>
-        </p:nvSpPr>
-        <p:spPr>
-          <a:xfrm>
-            <a:off x="731520" y="4206240"/>
-            <a:ext cx="5029200" cy="1005840"/>
-          </a:xfrm>
-          <a:prstGeom prst="rect">
-            <a:avLst/>
-          </a:prstGeom>
-          <a:noFill/>
-        </p:spPr>
-        <p:txBody>
-          <a:bodyPr wrap="none">
-            <a:spAutoFit/>
-          </a:bodyPr>
-          <a:lstStyle/>
-          <a:p>
-            <a:r>
-              <a:t>Control Level 3: Automated CI/CD Auditing</a:t>
+            <a:pPr>
+              <a:defRPr sz="2800"/>
+            </a:pPr>
+            <a:r>
+              <a:t>Executive Summary &amp; Milestones</a:t>
             </a:r>
           </a:p>
         </p:txBody>
       </p:sp>
       <p:pic>
         <p:nvPicPr>
-          <p:cNvPr id="6" name="Picture 5" descr="image.png"/>
+          <p:cNvPr id="3" name="Picture 2" descr="image.png"/>
           <p:cNvPicPr>
             <a:picLocks noChangeAspect="1"/>
           </p:cNvPicPr>
@@ -3406,14 +3521,227 @@
         </p:blipFill>
         <p:spPr>
           <a:xfrm>
-            <a:off x="6858000" y="1463040"/>
-            <a:ext cx="4389120" cy="4114800"/>
-          </a:xfrm>
-          <a:prstGeom prst="rect">
+            <a:off x="1280160" y="1828800"/>
+            <a:ext cx="2286000" cy="2286000"/>
+          </a:xfrm>
+          <a:prstGeom prst="ellipse">
             <a:avLst/>
           </a:prstGeom>
         </p:spPr>
       </p:pic>
+      <p:sp>
+        <p:nvSpPr>
+          <p:cNvPr id="4" name="TextBox 3"/>
+          <p:cNvSpPr txBox="1"/>
+          <p:nvPr/>
+        </p:nvSpPr>
+        <p:spPr>
+          <a:xfrm>
+            <a:off x="731520" y="4389120"/>
+            <a:ext cx="3383280" cy="1371600"/>
+          </a:xfrm>
+          <a:prstGeom prst="rect">
+            <a:avLst/>
+          </a:prstGeom>
+          <a:noFill/>
+        </p:spPr>
+        <p:txBody>
+          <a:bodyPr wrap="none">
+            <a:spAutoFit/>
+          </a:bodyPr>
+          <a:lstStyle/>
+          <a:p>
+            <a:pPr algn="ctr">
+              <a:defRPr sz="1300" b="1"/>
+            </a:pPr>
+            <a:r>
+              <a:t>Phase 1: Ingestion</a:t>
+            </a:r>
+          </a:p>
+        </p:txBody>
+      </p:sp>
+      <p:pic>
+        <p:nvPicPr>
+          <p:cNvPr id="5" name="Picture 4" descr="image.png"/>
+          <p:cNvPicPr>
+            <a:picLocks noChangeAspect="1"/>
+          </p:cNvPicPr>
+          <p:nvPr/>
+        </p:nvPicPr>
+        <p:blipFill>
+          <a:blip r:embed="rId3"/>
+          <a:stretch>
+            <a:fillRect/>
+          </a:stretch>
+        </p:blipFill>
+        <p:spPr>
+          <a:xfrm>
+            <a:off x="4892040" y="1828800"/>
+            <a:ext cx="2286000" cy="2286000"/>
+          </a:xfrm>
+          <a:prstGeom prst="ellipse">
+            <a:avLst/>
+          </a:prstGeom>
+        </p:spPr>
+      </p:pic>
+      <p:sp>
+        <p:nvSpPr>
+          <p:cNvPr id="6" name="TextBox 5"/>
+          <p:cNvSpPr txBox="1"/>
+          <p:nvPr/>
+        </p:nvSpPr>
+        <p:spPr>
+          <a:xfrm>
+            <a:off x="4343400" y="4389120"/>
+            <a:ext cx="3383280" cy="1371600"/>
+          </a:xfrm>
+          <a:prstGeom prst="rect">
+            <a:avLst/>
+          </a:prstGeom>
+          <a:noFill/>
+        </p:spPr>
+        <p:txBody>
+          <a:bodyPr wrap="none">
+            <a:spAutoFit/>
+          </a:bodyPr>
+          <a:lstStyle/>
+          <a:p>
+            <a:pPr algn="ctr">
+              <a:defRPr sz="1300" b="1"/>
+            </a:pPr>
+            <a:r>
+              <a:t>Phase 2: Alignment</a:t>
+            </a:r>
+          </a:p>
+        </p:txBody>
+      </p:sp>
+      <p:pic>
+        <p:nvPicPr>
+          <p:cNvPr id="7" name="Picture 6" descr="image.png"/>
+          <p:cNvPicPr>
+            <a:picLocks noChangeAspect="1"/>
+          </p:cNvPicPr>
+          <p:nvPr/>
+        </p:nvPicPr>
+        <p:blipFill>
+          <a:blip r:embed="rId4"/>
+          <a:stretch>
+            <a:fillRect/>
+          </a:stretch>
+        </p:blipFill>
+        <p:spPr>
+          <a:xfrm>
+            <a:off x="8503920" y="1828800"/>
+            <a:ext cx="2286000" cy="2286000"/>
+          </a:xfrm>
+          <a:prstGeom prst="ellipse">
+            <a:avLst/>
+          </a:prstGeom>
+        </p:spPr>
+      </p:pic>
+      <p:sp>
+        <p:nvSpPr>
+          <p:cNvPr id="8" name="TextBox 7"/>
+          <p:cNvSpPr txBox="1"/>
+          <p:nvPr/>
+        </p:nvSpPr>
+        <p:spPr>
+          <a:xfrm>
+            <a:off x="7955280" y="4389120"/>
+            <a:ext cx="3383280" cy="1371600"/>
+          </a:xfrm>
+          <a:prstGeom prst="rect">
+            <a:avLst/>
+          </a:prstGeom>
+          <a:noFill/>
+        </p:spPr>
+        <p:txBody>
+          <a:bodyPr wrap="none">
+            <a:spAutoFit/>
+          </a:bodyPr>
+          <a:lstStyle/>
+          <a:p>
+            <a:pPr algn="ctr">
+              <a:defRPr sz="1300" b="1"/>
+            </a:pPr>
+            <a:r>
+              <a:t>Phase 3: Generation</a:t>
+            </a:r>
+          </a:p>
+        </p:txBody>
+      </p:sp>
+      <p:sp>
+        <p:nvSpPr>
+          <p:cNvPr id="9" name="TextBox 8"/>
+          <p:cNvSpPr txBox="1"/>
+          <p:nvPr/>
+        </p:nvSpPr>
+        <p:spPr>
+          <a:xfrm>
+            <a:off x="731520" y="6400800"/>
+            <a:ext cx="4114800" cy="320040"/>
+          </a:xfrm>
+          <a:prstGeom prst="rect">
+            <a:avLst/>
+          </a:prstGeom>
+          <a:noFill/>
+        </p:spPr>
+        <p:txBody>
+          <a:bodyPr wrap="none">
+            <a:spAutoFit/>
+          </a:bodyPr>
+          <a:lstStyle/>
+          <a:p>
+            <a:pPr>
+              <a:defRPr sz="850">
+                <a:solidFill>
+                  <a:srgbClr val="8C96A0"/>
+                </a:solidFill>
+                <a:latin typeface="Calibri"/>
+              </a:defRPr>
+            </a:pPr>
+            <a:r>
+              <a:t>PRESENTATION TITLE</a:t>
+            </a:r>
+          </a:p>
+        </p:txBody>
+      </p:sp>
+      <p:sp>
+        <p:nvSpPr>
+          <p:cNvPr id="10" name="TextBox 9"/>
+          <p:cNvSpPr txBox="1"/>
+          <p:nvPr/>
+        </p:nvSpPr>
+        <p:spPr>
+          <a:xfrm>
+            <a:off x="10972800" y="6400800"/>
+            <a:ext cx="548640" cy="320040"/>
+          </a:xfrm>
+          <a:prstGeom prst="rect">
+            <a:avLst/>
+          </a:prstGeom>
+          <a:noFill/>
+        </p:spPr>
+        <p:txBody>
+          <a:bodyPr wrap="none">
+            <a:spAutoFit/>
+          </a:bodyPr>
+          <a:lstStyle/>
+          <a:p>
+            <a:pPr>
+              <a:defRPr sz="850">
+                <a:solidFill>
+                  <a:srgbClr val="8C96A0"/>
+                </a:solidFill>
+                <a:latin typeface="Calibri"/>
+              </a:defRPr>
+            </a:pPr>
+            <a:r>
+              <a:t>11</a:t>
+            </a:r>
+          </a:p>
+        </p:txBody>
+      </p:sp>
     </p:spTree>
   </p:cSld>
   <p:clrMapOvr>
@@ -3440,8 +3768,8 @@
         </p:nvSpPr>
         <p:spPr>
           <a:xfrm>
-            <a:off x="1371600" y="2286000"/>
-            <a:ext cx="8229600" cy="1097280"/>
+            <a:off x="731520" y="2011680"/>
+            <a:ext cx="5486400" cy="1097280"/>
           </a:xfrm>
           <a:prstGeom prst="rect">
             <a:avLst/>
@@ -3454,6 +3782,11 @@
           </a:bodyPr>
           <a:lstStyle/>
           <a:p>
+            <a:pPr>
+              <a:defRPr sz="3600">
+                <a:latin typeface="Times New Roman"/>
+              </a:defRPr>
+            </a:pPr>
             <a:r>
               <a:t>Thank You</a:t>
             </a:r>
@@ -3468,8 +3801,8 @@
         </p:nvSpPr>
         <p:spPr>
           <a:xfrm>
-            <a:off x="1371600" y="3474720"/>
-            <a:ext cx="8229600" cy="731520"/>
+            <a:off x="731520" y="3291840"/>
+            <a:ext cx="5486400" cy="1371600"/>
           </a:xfrm>
           <a:prstGeom prst="rect">
             <a:avLst/>
@@ -3482,12 +3815,51 @@
           </a:bodyPr>
           <a:lstStyle/>
           <a:p>
-            <a:r>
-              <a:t>Contact: team@brandmorph.com | https://brandmorph-tau.vercel.app</a:t>
-            </a:r>
-          </a:p>
-        </p:txBody>
-      </p:sp>
+            <a:pPr>
+              <a:defRPr sz="1300">
+                <a:solidFill>
+                  <a:srgbClr val="64748B"/>
+                </a:solidFill>
+              </a:defRPr>
+            </a:pPr>
+            <a:r>
+              <a:t>Website: https://brandmorph-tau.vercel.app</a:t>
+            </a:r>
+            <a:br/>
+            <a:r>
+              <a:t>Inquiries: team@brandmorph.com</a:t>
+            </a:r>
+            <a:br/>
+            <a:r>
+              <a:t>Headquarters: San Francisco, CA</a:t>
+            </a:r>
+          </a:p>
+        </p:txBody>
+      </p:sp>
+      <p:pic>
+        <p:nvPicPr>
+          <p:cNvPr id="4" name="Picture 3" descr="image.png"/>
+          <p:cNvPicPr>
+            <a:picLocks noChangeAspect="1"/>
+          </p:cNvPicPr>
+          <p:nvPr/>
+        </p:nvPicPr>
+        <p:blipFill>
+          <a:blip r:embed="rId2"/>
+          <a:stretch>
+            <a:fillRect/>
+          </a:stretch>
+        </p:blipFill>
+        <p:spPr>
+          <a:xfrm>
+            <a:off x="6858000" y="1645920"/>
+            <a:ext cx="4389120" cy="3840480"/>
+          </a:xfrm>
+          <a:prstGeom prst="rect">
+            <a:avLst/>
+          </a:prstGeom>
+        </p:spPr>
+      </p:pic>
     </p:spTree>
   </p:cSld>
   <p:clrMapOvr>
@@ -3514,8 +3886,8 @@
         </p:nvSpPr>
         <p:spPr>
           <a:xfrm>
-            <a:off x="457200" y="457200"/>
-            <a:ext cx="7315200" cy="731520"/>
+            <a:off x="731520" y="548640"/>
+            <a:ext cx="6400800" cy="731520"/>
           </a:xfrm>
           <a:prstGeom prst="rect">
             <a:avLst/>
@@ -3528,6 +3900,11 @@
           </a:bodyPr>
           <a:lstStyle/>
           <a:p>
+            <a:pPr>
+              <a:defRPr sz="2800">
+                <a:latin typeface="Times New Roman"/>
+              </a:defRPr>
+            </a:pPr>
             <a:r>
               <a:t>Executive Agenda</a:t>
             </a:r>
@@ -3542,8 +3919,8 @@
         </p:nvSpPr>
         <p:spPr>
           <a:xfrm>
-            <a:off x="914400" y="1371600"/>
-            <a:ext cx="4572000" cy="731520"/>
+            <a:off x="731520" y="1645920"/>
+            <a:ext cx="5303520" cy="731520"/>
           </a:xfrm>
           <a:prstGeom prst="rect">
             <a:avLst/>
@@ -3556,8 +3933,13 @@
           </a:bodyPr>
           <a:lstStyle/>
           <a:p>
-            <a:r>
-              <a:t>Agenda Item 1: Global Strategy and Execution</a:t>
+            <a:pPr>
+              <a:defRPr sz="1400" b="1">
+                <a:latin typeface="Calibri"/>
+              </a:defRPr>
+            </a:pPr>
+            <a:r>
+              <a:t>01. Corporate Mission &amp; Strategic Horizon</a:t>
             </a:r>
           </a:p>
         </p:txBody>
@@ -3570,8 +3952,8 @@
         </p:nvSpPr>
         <p:spPr>
           <a:xfrm>
-            <a:off x="914400" y="2468880"/>
-            <a:ext cx="4572000" cy="731520"/>
+            <a:off x="731520" y="2697480"/>
+            <a:ext cx="5303520" cy="731520"/>
           </a:xfrm>
           <a:prstGeom prst="rect">
             <a:avLst/>
@@ -3584,8 +3966,13 @@
           </a:bodyPr>
           <a:lstStyle/>
           <a:p>
-            <a:r>
-              <a:t>Agenda Item 2: Global Strategy and Execution</a:t>
+            <a:pPr>
+              <a:defRPr sz="1400" b="1">
+                <a:latin typeface="Calibri"/>
+              </a:defRPr>
+            </a:pPr>
+            <a:r>
+              <a:t>02. Operational Architecture &amp; Cloud Scale</a:t>
             </a:r>
           </a:p>
         </p:txBody>
@@ -3598,8 +3985,8 @@
         </p:nvSpPr>
         <p:spPr>
           <a:xfrm>
-            <a:off x="914400" y="3566160"/>
-            <a:ext cx="4572000" cy="731520"/>
+            <a:off x="731520" y="3749039"/>
+            <a:ext cx="5303520" cy="731520"/>
           </a:xfrm>
           <a:prstGeom prst="rect">
             <a:avLst/>
@@ -3612,8 +3999,13 @@
           </a:bodyPr>
           <a:lstStyle/>
           <a:p>
-            <a:r>
-              <a:t>Agenda Item 3: Global Strategy and Execution</a:t>
+            <a:pPr>
+              <a:defRPr sz="1400" b="1">
+                <a:latin typeface="Calibri"/>
+              </a:defRPr>
+            </a:pPr>
+            <a:r>
+              <a:t>03. Global Financial &amp; Unit Economics</a:t>
             </a:r>
           </a:p>
         </p:txBody>
@@ -3626,8 +4018,8 @@
         </p:nvSpPr>
         <p:spPr>
           <a:xfrm>
-            <a:off x="914400" y="4663440"/>
-            <a:ext cx="4572000" cy="731520"/>
+            <a:off x="731520" y="4800600"/>
+            <a:ext cx="5303520" cy="731520"/>
           </a:xfrm>
           <a:prstGeom prst="rect">
             <a:avLst/>
@@ -3640,8 +4032,13 @@
           </a:bodyPr>
           <a:lstStyle/>
           <a:p>
-            <a:r>
-              <a:t>Agenda Item 4: Global Strategy and Execution</a:t>
+            <a:pPr>
+              <a:defRPr sz="1400" b="1">
+                <a:latin typeface="Calibri"/>
+              </a:defRPr>
+            </a:pPr>
+            <a:r>
+              <a:t>04. Risk Governance &amp; Execution Roadmap</a:t>
             </a:r>
           </a:p>
         </p:txBody>
@@ -3662,8 +4059,8 @@
         </p:blipFill>
         <p:spPr>
           <a:xfrm>
-            <a:off x="6858000" y="1371600"/>
-            <a:ext cx="4114800" cy="1828800"/>
+            <a:off x="6583680" y="1645920"/>
+            <a:ext cx="4389120" cy="2011680"/>
           </a:xfrm>
           <a:prstGeom prst="rect">
             <a:avLst/>
@@ -3679,21 +4076,93 @@
           <p:nvPr/>
         </p:nvPicPr>
         <p:blipFill>
-          <a:blip r:embed="rId2"/>
+          <a:blip r:embed="rId3"/>
           <a:stretch>
             <a:fillRect/>
           </a:stretch>
         </p:blipFill>
         <p:spPr>
           <a:xfrm>
-            <a:off x="6858000" y="3657600"/>
-            <a:ext cx="4114800" cy="1828800"/>
+            <a:off x="6583680" y="3931920"/>
+            <a:ext cx="4389120" cy="2011680"/>
           </a:xfrm>
           <a:prstGeom prst="rect">
             <a:avLst/>
           </a:prstGeom>
         </p:spPr>
       </p:pic>
+      <p:sp>
+        <p:nvSpPr>
+          <p:cNvPr id="9" name="TextBox 8"/>
+          <p:cNvSpPr txBox="1"/>
+          <p:nvPr/>
+        </p:nvSpPr>
+        <p:spPr>
+          <a:xfrm>
+            <a:off x="731520" y="6400800"/>
+            <a:ext cx="4114800" cy="320040"/>
+          </a:xfrm>
+          <a:prstGeom prst="rect">
+            <a:avLst/>
+          </a:prstGeom>
+          <a:noFill/>
+        </p:spPr>
+        <p:txBody>
+          <a:bodyPr wrap="none">
+            <a:spAutoFit/>
+          </a:bodyPr>
+          <a:lstStyle/>
+          <a:p>
+            <a:pPr>
+              <a:defRPr sz="850">
+                <a:solidFill>
+                  <a:srgbClr val="8C96A0"/>
+                </a:solidFill>
+                <a:latin typeface="Calibri"/>
+              </a:defRPr>
+            </a:pPr>
+            <a:r>
+              <a:t>PRESENTATION TITLE</a:t>
+            </a:r>
+          </a:p>
+        </p:txBody>
+      </p:sp>
+      <p:sp>
+        <p:nvSpPr>
+          <p:cNvPr id="10" name="TextBox 9"/>
+          <p:cNvSpPr txBox="1"/>
+          <p:nvPr/>
+        </p:nvSpPr>
+        <p:spPr>
+          <a:xfrm>
+            <a:off x="10972800" y="6400800"/>
+            <a:ext cx="548640" cy="320040"/>
+          </a:xfrm>
+          <a:prstGeom prst="rect">
+            <a:avLst/>
+          </a:prstGeom>
+          <a:noFill/>
+        </p:spPr>
+        <p:txBody>
+          <a:bodyPr wrap="none">
+            <a:spAutoFit/>
+          </a:bodyPr>
+          <a:lstStyle/>
+          <a:p>
+            <a:pPr>
+              <a:defRPr sz="850">
+                <a:solidFill>
+                  <a:srgbClr val="8C96A0"/>
+                </a:solidFill>
+                <a:latin typeface="Calibri"/>
+              </a:defRPr>
+            </a:pPr>
+            <a:r>
+              <a:t>2</a:t>
+            </a:r>
+          </a:p>
+        </p:txBody>
+      </p:sp>
     </p:spTree>
   </p:cSld>
   <p:clrMapOvr>
@@ -3721,7 +4190,7 @@
         <p:spPr>
           <a:xfrm>
             <a:off x="731520" y="548640"/>
-            <a:ext cx="6400800" cy="731520"/>
+            <a:ext cx="6858000" cy="731520"/>
           </a:xfrm>
           <a:prstGeom prst="rect">
             <a:avLst/>
@@ -3734,6 +4203,9 @@
           </a:bodyPr>
           <a:lstStyle/>
           <a:p>
+            <a:pPr>
+              <a:defRPr sz="2800"/>
+            </a:pPr>
             <a:r>
               <a:t>Market Growth Opportunities</a:t>
             </a:r>
@@ -3748,8 +4220,8 @@
         </p:nvSpPr>
         <p:spPr>
           <a:xfrm>
-            <a:off x="731520" y="1463040"/>
-            <a:ext cx="5029200" cy="1097280"/>
+            <a:off x="731520" y="1645920"/>
+            <a:ext cx="5303520" cy="1188720"/>
           </a:xfrm>
           <a:prstGeom prst="rect">
             <a:avLst/>
@@ -3763,15 +4235,18 @@
           <a:lstStyle/>
           <a:p>
             <a:pPr>
-              <a:defRPr b="1"/>
-            </a:pPr>
-            <a:r>
-              <a:t>Pillar 1: Accelerated Delivery</a:t>
-            </a:r>
-          </a:p>
-          <a:p>
-            <a:r>
-              <a:t>Expanding cloud adoption and cross-functional operations with measurable outcomes.</a:t>
+              <a:defRPr sz="1300" b="1"/>
+            </a:pPr>
+            <a:r>
+              <a:t>Pillar 01: Intelligent Pipeline</a:t>
+            </a:r>
+          </a:p>
+          <a:p>
+            <a:pPr>
+              <a:defRPr sz="1100"/>
+            </a:pPr>
+            <a:r>
+              <a:t>Automated slide governance guaranteeing brand consistency across all global teams.</a:t>
             </a:r>
           </a:p>
         </p:txBody>
@@ -3784,8 +4259,8 @@
         </p:nvSpPr>
         <p:spPr>
           <a:xfrm>
-            <a:off x="731520" y="2926080"/>
-            <a:ext cx="5029200" cy="1097280"/>
+            <a:off x="731520" y="3108960"/>
+            <a:ext cx="5303520" cy="1188720"/>
           </a:xfrm>
           <a:prstGeom prst="rect">
             <a:avLst/>
@@ -3799,15 +4274,18 @@
           <a:lstStyle/>
           <a:p>
             <a:pPr>
-              <a:defRPr b="1"/>
-            </a:pPr>
-            <a:r>
-              <a:t>Pillar 2: Accelerated Delivery</a:t>
-            </a:r>
-          </a:p>
-          <a:p>
-            <a:r>
-              <a:t>Expanding cloud adoption and cross-functional operations with measurable outcomes.</a:t>
+              <a:defRPr sz="1300" b="1"/>
+            </a:pPr>
+            <a:r>
+              <a:t>Pillar 02: Neural Alignment</a:t>
+            </a:r>
+          </a:p>
+          <a:p>
+            <a:pPr>
+              <a:defRPr sz="1100"/>
+            </a:pPr>
+            <a:r>
+              <a:t>Real-time layout classification with sub-millisecond inference and spatial consensus.</a:t>
             </a:r>
           </a:p>
         </p:txBody>
@@ -3820,8 +4298,8 @@
         </p:nvSpPr>
         <p:spPr>
           <a:xfrm>
-            <a:off x="731520" y="4389120"/>
-            <a:ext cx="5029200" cy="1097280"/>
+            <a:off x="731520" y="4572000"/>
+            <a:ext cx="5303520" cy="1188720"/>
           </a:xfrm>
           <a:prstGeom prst="rect">
             <a:avLst/>
@@ -3835,15 +4313,18 @@
           <a:lstStyle/>
           <a:p>
             <a:pPr>
-              <a:defRPr b="1"/>
-            </a:pPr>
-            <a:r>
-              <a:t>Pillar 3: Accelerated Delivery</a:t>
-            </a:r>
-          </a:p>
-          <a:p>
-            <a:r>
-              <a:t>Expanding cloud adoption and cross-functional operations with measurable outcomes.</a:t>
+              <a:defRPr sz="1300" b="1"/>
+            </a:pPr>
+            <a:r>
+              <a:t>Pillar 03: Scalable Operations</a:t>
+            </a:r>
+          </a:p>
+          <a:p>
+            <a:pPr>
+              <a:defRPr sz="1100"/>
+            </a:pPr>
+            <a:r>
+              <a:t>Enterprise-grade OpenXML decompilation with full fidelity asset preservation.</a:t>
             </a:r>
           </a:p>
         </p:txBody>
@@ -3864,14 +4345,86 @@
         </p:blipFill>
         <p:spPr>
           <a:xfrm>
-            <a:off x="6583680" y="1463040"/>
-            <a:ext cx="4754880" cy="4114800"/>
+            <a:off x="6583680" y="1645920"/>
+            <a:ext cx="4389120" cy="4206240"/>
           </a:xfrm>
           <a:prstGeom prst="rect">
             <a:avLst/>
           </a:prstGeom>
         </p:spPr>
       </p:pic>
+      <p:sp>
+        <p:nvSpPr>
+          <p:cNvPr id="7" name="TextBox 6"/>
+          <p:cNvSpPr txBox="1"/>
+          <p:nvPr/>
+        </p:nvSpPr>
+        <p:spPr>
+          <a:xfrm>
+            <a:off x="731520" y="6400800"/>
+            <a:ext cx="4114800" cy="320040"/>
+          </a:xfrm>
+          <a:prstGeom prst="rect">
+            <a:avLst/>
+          </a:prstGeom>
+          <a:noFill/>
+        </p:spPr>
+        <p:txBody>
+          <a:bodyPr wrap="none">
+            <a:spAutoFit/>
+          </a:bodyPr>
+          <a:lstStyle/>
+          <a:p>
+            <a:pPr>
+              <a:defRPr sz="850">
+                <a:solidFill>
+                  <a:srgbClr val="8C96A0"/>
+                </a:solidFill>
+                <a:latin typeface="Calibri"/>
+              </a:defRPr>
+            </a:pPr>
+            <a:r>
+              <a:t>PRESENTATION TITLE</a:t>
+            </a:r>
+          </a:p>
+        </p:txBody>
+      </p:sp>
+      <p:sp>
+        <p:nvSpPr>
+          <p:cNvPr id="8" name="TextBox 7"/>
+          <p:cNvSpPr txBox="1"/>
+          <p:nvPr/>
+        </p:nvSpPr>
+        <p:spPr>
+          <a:xfrm>
+            <a:off x="10972800" y="6400800"/>
+            <a:ext cx="548640" cy="320040"/>
+          </a:xfrm>
+          <a:prstGeom prst="rect">
+            <a:avLst/>
+          </a:prstGeom>
+          <a:noFill/>
+        </p:spPr>
+        <p:txBody>
+          <a:bodyPr wrap="none">
+            <a:spAutoFit/>
+          </a:bodyPr>
+          <a:lstStyle/>
+          <a:p>
+            <a:pPr>
+              <a:defRPr sz="850">
+                <a:solidFill>
+                  <a:srgbClr val="8C96A0"/>
+                </a:solidFill>
+                <a:latin typeface="Calibri"/>
+              </a:defRPr>
+            </a:pPr>
+            <a:r>
+              <a:t>3</a:t>
+            </a:r>
+          </a:p>
+        </p:txBody>
+      </p:sp>
     </p:spTree>
   </p:cSld>
   <p:clrMapOvr>
@@ -3898,8 +4451,8 @@
         </p:nvSpPr>
         <p:spPr>
           <a:xfrm>
-            <a:off x="1371600" y="2011680"/>
-            <a:ext cx="8229600" cy="914400"/>
+            <a:off x="731520" y="2103120"/>
+            <a:ext cx="5303520" cy="1097280"/>
           </a:xfrm>
           <a:prstGeom prst="rect">
             <a:avLst/>
@@ -3912,6 +4465,11 @@
           </a:bodyPr>
           <a:lstStyle/>
           <a:p>
+            <a:pPr>
+              <a:defRPr sz="3600">
+                <a:latin typeface="Times New Roman"/>
+              </a:defRPr>
+            </a:pPr>
             <a:r>
               <a:t>Topic One</a:t>
             </a:r>
@@ -3926,8 +4484,8 @@
         </p:nvSpPr>
         <p:spPr>
           <a:xfrm>
-            <a:off x="1371600" y="3017520"/>
-            <a:ext cx="8229600" cy="731520"/>
+            <a:off x="731520" y="3291840"/>
+            <a:ext cx="5303520" cy="1097280"/>
           </a:xfrm>
           <a:prstGeom prst="rect">
             <a:avLst/>
@@ -3940,8 +4498,15 @@
           </a:bodyPr>
           <a:lstStyle/>
           <a:p>
-            <a:r>
-              <a:t>Operational Excellence and Engineering Delivery</a:t>
+            <a:pPr>
+              <a:defRPr sz="1600">
+                <a:solidFill>
+                  <a:srgbClr val="64748B"/>
+                </a:solidFill>
+              </a:defRPr>
+            </a:pPr>
+            <a:r>
+              <a:t>Engineering Architecture &amp; Scalable Infrastructure</a:t>
             </a:r>
           </a:p>
         </p:txBody>
@@ -3962,14 +4527,86 @@
         </p:blipFill>
         <p:spPr>
           <a:xfrm>
-            <a:off x="7315200" y="1371600"/>
-            <a:ext cx="4114800" cy="4114800"/>
-          </a:xfrm>
-          <a:prstGeom prst="rect">
+            <a:off x="6583680" y="1463040"/>
+            <a:ext cx="4206240" cy="4206240"/>
+          </a:xfrm>
+          <a:prstGeom prst="ellipse">
             <a:avLst/>
           </a:prstGeom>
         </p:spPr>
       </p:pic>
+      <p:sp>
+        <p:nvSpPr>
+          <p:cNvPr id="5" name="TextBox 4"/>
+          <p:cNvSpPr txBox="1"/>
+          <p:nvPr/>
+        </p:nvSpPr>
+        <p:spPr>
+          <a:xfrm>
+            <a:off x="731520" y="6400800"/>
+            <a:ext cx="4114800" cy="320040"/>
+          </a:xfrm>
+          <a:prstGeom prst="rect">
+            <a:avLst/>
+          </a:prstGeom>
+          <a:noFill/>
+        </p:spPr>
+        <p:txBody>
+          <a:bodyPr wrap="none">
+            <a:spAutoFit/>
+          </a:bodyPr>
+          <a:lstStyle/>
+          <a:p>
+            <a:pPr>
+              <a:defRPr sz="850">
+                <a:solidFill>
+                  <a:srgbClr val="8C96A0"/>
+                </a:solidFill>
+                <a:latin typeface="Calibri"/>
+              </a:defRPr>
+            </a:pPr>
+            <a:r>
+              <a:t>PRESENTATION TITLE</a:t>
+            </a:r>
+          </a:p>
+        </p:txBody>
+      </p:sp>
+      <p:sp>
+        <p:nvSpPr>
+          <p:cNvPr id="6" name="TextBox 5"/>
+          <p:cNvSpPr txBox="1"/>
+          <p:nvPr/>
+        </p:nvSpPr>
+        <p:spPr>
+          <a:xfrm>
+            <a:off x="10972800" y="6400800"/>
+            <a:ext cx="548640" cy="320040"/>
+          </a:xfrm>
+          <a:prstGeom prst="rect">
+            <a:avLst/>
+          </a:prstGeom>
+          <a:noFill/>
+        </p:spPr>
+        <p:txBody>
+          <a:bodyPr wrap="none">
+            <a:spAutoFit/>
+          </a:bodyPr>
+          <a:lstStyle/>
+          <a:p>
+            <a:pPr>
+              <a:defRPr sz="850">
+                <a:solidFill>
+                  <a:srgbClr val="8C96A0"/>
+                </a:solidFill>
+                <a:latin typeface="Calibri"/>
+              </a:defRPr>
+            </a:pPr>
+            <a:r>
+              <a:t>4</a:t>
+            </a:r>
+          </a:p>
+        </p:txBody>
+      </p:sp>
     </p:spTree>
   </p:cSld>
   <p:clrMapOvr>
@@ -3996,7 +4633,7 @@
         </p:nvSpPr>
         <p:spPr>
           <a:xfrm>
-            <a:off x="914400" y="457200"/>
+            <a:off x="731520" y="548640"/>
             <a:ext cx="7315200" cy="731520"/>
           </a:xfrm>
           <a:prstGeom prst="rect">
@@ -4010,6 +4647,9 @@
           </a:bodyPr>
           <a:lstStyle/>
           <a:p>
+            <a:pPr>
+              <a:defRPr sz="2800"/>
+            </a:pPr>
             <a:r>
               <a:t>Financial Performance Metrics</a:t>
             </a:r>
@@ -4025,8 +4665,8 @@
           <p:nvPr/>
         </p:nvGraphicFramePr>
         <p:xfrm>
-          <a:off x="914400" y="1645920"/>
-          <a:ext cx="10058400" cy="4114800"/>
+          <a:off x="731520" y="1645920"/>
+          <a:ext cx="10241280" cy="4023360"/>
         </p:xfrm>
         <a:graphic>
           <a:graphicData uri="http://schemas.openxmlformats.org/drawingml/2006/table">
@@ -4035,18 +4675,96 @@
                 <a:tableStyleId>{5C22544A-7EE6-4342-B048-85BDC9FD1C3A}</a:tableStyleId>
               </a:tblPr>
               <a:tblGrid>
-                <a:gridCol w="3352800"/>
-                <a:gridCol w="3352800"/>
-                <a:gridCol w="3352800"/>
+                <a:gridCol w="3413760"/>
+                <a:gridCol w="3413760"/>
+                <a:gridCol w="3413760"/>
               </a:tblGrid>
-              <a:tr h="1028700">
+              <a:tr h="1005840">
                 <a:tc>
                   <a:txBody>
                     <a:bodyPr/>
                     <a:lstStyle/>
                     <a:p>
+                      <a:pPr>
+                        <a:defRPr b="1" sz="1200">
+                          <a:solidFill>
+                            <a:srgbClr val="001F33"/>
+                          </a:solidFill>
+                        </a:defRPr>
+                      </a:pPr>
                       <a:r>
                         <a:t>Metric</a:t>
+                      </a:r>
+                    </a:p>
+                  </a:txBody>
+                  <a:tcPr>
+                    <a:solidFill>
+                      <a:srgbClr val="FFB81C"/>
+                    </a:solidFill>
+                  </a:tcPr>
+                </a:tc>
+                <a:tc>
+                  <a:txBody>
+                    <a:bodyPr/>
+                    <a:lstStyle/>
+                    <a:p>
+                      <a:pPr>
+                        <a:defRPr b="1" sz="1200">
+                          <a:solidFill>
+                            <a:srgbClr val="001F33"/>
+                          </a:solidFill>
+                        </a:defRPr>
+                      </a:pPr>
+                      <a:r>
+                        <a:t>FY24 Actual</a:t>
+                      </a:r>
+                    </a:p>
+                  </a:txBody>
+                  <a:tcPr>
+                    <a:solidFill>
+                      <a:srgbClr val="FFB81C"/>
+                    </a:solidFill>
+                  </a:tcPr>
+                </a:tc>
+                <a:tc>
+                  <a:txBody>
+                    <a:bodyPr/>
+                    <a:lstStyle/>
+                    <a:p>
+                      <a:pPr>
+                        <a:defRPr b="1" sz="1200">
+                          <a:solidFill>
+                            <a:srgbClr val="001F33"/>
+                          </a:solidFill>
+                        </a:defRPr>
+                      </a:pPr>
+                      <a:r>
+                        <a:t>FY25 Plan</a:t>
+                      </a:r>
+                    </a:p>
+                  </a:txBody>
+                  <a:tcPr>
+                    <a:solidFill>
+                      <a:srgbClr val="FFB81C"/>
+                    </a:solidFill>
+                  </a:tcPr>
+                </a:tc>
+              </a:tr>
+              <a:tr h="1005840">
+                <a:tc>
+                  <a:txBody>
+                    <a:bodyPr/>
+                    <a:lstStyle/>
+                    <a:p>
+                      <a:pPr>
+                        <a:defRPr sz="1100">
+                          <a:solidFill>
+                            <a:srgbClr val="18181B"/>
+                          </a:solidFill>
+                        </a:defRPr>
+                      </a:pPr>
+                      <a:r>
+                        <a:t>Total Revenue ($M)</a:t>
                       </a:r>
                     </a:p>
                   </a:txBody>
@@ -4057,44 +4775,13 @@
                     <a:bodyPr/>
                     <a:lstStyle/>
                     <a:p>
-                      <a:r>
-                        <a:t>FY24 Actual</a:t>
-                      </a:r>
-                    </a:p>
-                  </a:txBody>
-                  <a:tcPr/>
-                </a:tc>
-                <a:tc>
-                  <a:txBody>
-                    <a:bodyPr/>
-                    <a:lstStyle/>
-                    <a:p>
-                      <a:r>
-                        <a:t>FY25 Plan</a:t>
-                      </a:r>
-                    </a:p>
-                  </a:txBody>
-                  <a:tcPr/>
-                </a:tc>
-              </a:tr>
-              <a:tr h="1028700">
-                <a:tc>
-                  <a:txBody>
-                    <a:bodyPr/>
-                    <a:lstStyle/>
-                    <a:p>
-                      <a:r>
-                        <a:t>Revenue ($M)</a:t>
-                      </a:r>
-                    </a:p>
-                  </a:txBody>
-                  <a:tcPr/>
-                </a:tc>
-                <a:tc>
-                  <a:txBody>
-                    <a:bodyPr/>
-                    <a:lstStyle/>
-                    <a:p>
+                      <a:pPr>
+                        <a:defRPr sz="1100">
+                          <a:solidFill>
+                            <a:srgbClr val="18181B"/>
+                          </a:solidFill>
+                        </a:defRPr>
+                      </a:pPr>
                       <a:r>
                         <a:t>$124.5</a:t>
                       </a:r>
@@ -4107,6 +4794,13 @@
                     <a:bodyPr/>
                     <a:lstStyle/>
                     <a:p>
+                      <a:pPr>
+                        <a:defRPr sz="1100">
+                          <a:solidFill>
+                            <a:srgbClr val="18181B"/>
+                          </a:solidFill>
+                        </a:defRPr>
+                      </a:pPr>
                       <a:r>
                         <a:t>$168.0</a:t>
                       </a:r>
@@ -4115,14 +4809,21 @@
                   <a:tcPr/>
                 </a:tc>
               </a:tr>
-              <a:tr h="1028700">
+              <a:tr h="1005840">
                 <a:tc>
                   <a:txBody>
                     <a:bodyPr/>
                     <a:lstStyle/>
                     <a:p>
+                      <a:pPr>
+                        <a:defRPr sz="1100">
+                          <a:solidFill>
+                            <a:srgbClr val="18181B"/>
+                          </a:solidFill>
+                        </a:defRPr>
+                      </a:pPr>
                       <a:r>
-                        <a:t>Operating Margin</a:t>
+                        <a:t>Gross Margin (%)</a:t>
                       </a:r>
                     </a:p>
                   </a:txBody>
@@ -4133,8 +4834,15 @@
                     <a:bodyPr/>
                     <a:lstStyle/>
                     <a:p>
+                      <a:pPr>
+                        <a:defRPr sz="1100">
+                          <a:solidFill>
+                            <a:srgbClr val="18181B"/>
+                          </a:solidFill>
+                        </a:defRPr>
+                      </a:pPr>
                       <a:r>
-                        <a:t>22.4%</a:t>
+                        <a:t>74.2%</a:t>
                       </a:r>
                     </a:p>
                   </a:txBody>
@@ -4145,22 +4853,36 @@
                     <a:bodyPr/>
                     <a:lstStyle/>
                     <a:p>
+                      <a:pPr>
+                        <a:defRPr sz="1100">
+                          <a:solidFill>
+                            <a:srgbClr val="18181B"/>
+                          </a:solidFill>
+                        </a:defRPr>
+                      </a:pPr>
                       <a:r>
-                        <a:t>26.8%</a:t>
+                        <a:t>78.5%</a:t>
                       </a:r>
                     </a:p>
                   </a:txBody>
                   <a:tcPr/>
                 </a:tc>
               </a:tr>
-              <a:tr h="1028700">
+              <a:tr h="1005840">
                 <a:tc>
                   <a:txBody>
                     <a:bodyPr/>
                     <a:lstStyle/>
                     <a:p>
+                      <a:pPr>
+                        <a:defRPr sz="1100">
+                          <a:solidFill>
+                            <a:srgbClr val="18181B"/>
+                          </a:solidFill>
+                        </a:defRPr>
+                      </a:pPr>
                       <a:r>
-                        <a:t>Customer Retention</a:t>
+                        <a:t>Customer Retention (%)</a:t>
                       </a:r>
                     </a:p>
                   </a:txBody>
@@ -4171,6 +4893,13 @@
                     <a:bodyPr/>
                     <a:lstStyle/>
                     <a:p>
+                      <a:pPr>
+                        <a:defRPr sz="1100">
+                          <a:solidFill>
+                            <a:srgbClr val="18181B"/>
+                          </a:solidFill>
+                        </a:defRPr>
+                      </a:pPr>
                       <a:r>
                         <a:t>96.5%</a:t>
                       </a:r>
@@ -4183,6 +4912,13 @@
                     <a:bodyPr/>
                     <a:lstStyle/>
                     <a:p>
+                      <a:pPr>
+                        <a:defRPr sz="1100">
+                          <a:solidFill>
+                            <a:srgbClr val="18181B"/>
+                          </a:solidFill>
+                        </a:defRPr>
+                      </a:pPr>
                       <a:r>
                         <a:t>98.5%</a:t>
                       </a:r>
@@ -4195,6 +4931,78 @@
           </a:graphicData>
         </a:graphic>
       </p:graphicFrame>
+      <p:sp>
+        <p:nvSpPr>
+          <p:cNvPr id="4" name="TextBox 3"/>
+          <p:cNvSpPr txBox="1"/>
+          <p:nvPr/>
+        </p:nvSpPr>
+        <p:spPr>
+          <a:xfrm>
+            <a:off x="731520" y="6400800"/>
+            <a:ext cx="4114800" cy="320040"/>
+          </a:xfrm>
+          <a:prstGeom prst="rect">
+            <a:avLst/>
+          </a:prstGeom>
+          <a:noFill/>
+        </p:spPr>
+        <p:txBody>
+          <a:bodyPr wrap="none">
+            <a:spAutoFit/>
+          </a:bodyPr>
+          <a:lstStyle/>
+          <a:p>
+            <a:pPr>
+              <a:defRPr sz="850">
+                <a:solidFill>
+                  <a:srgbClr val="8C96A0"/>
+                </a:solidFill>
+                <a:latin typeface="Calibri"/>
+              </a:defRPr>
+            </a:pPr>
+            <a:r>
+              <a:t>PRESENTATION TITLE</a:t>
+            </a:r>
+          </a:p>
+        </p:txBody>
+      </p:sp>
+      <p:sp>
+        <p:nvSpPr>
+          <p:cNvPr id="5" name="TextBox 4"/>
+          <p:cNvSpPr txBox="1"/>
+          <p:nvPr/>
+        </p:nvSpPr>
+        <p:spPr>
+          <a:xfrm>
+            <a:off x="10972800" y="6400800"/>
+            <a:ext cx="548640" cy="320040"/>
+          </a:xfrm>
+          <a:prstGeom prst="rect">
+            <a:avLst/>
+          </a:prstGeom>
+          <a:noFill/>
+        </p:spPr>
+        <p:txBody>
+          <a:bodyPr wrap="none">
+            <a:spAutoFit/>
+          </a:bodyPr>
+          <a:lstStyle/>
+          <a:p>
+            <a:pPr>
+              <a:defRPr sz="850">
+                <a:solidFill>
+                  <a:srgbClr val="8C96A0"/>
+                </a:solidFill>
+                <a:latin typeface="Calibri"/>
+              </a:defRPr>
+            </a:pPr>
+            <a:r>
+              <a:t>5</a:t>
+            </a:r>
+          </a:p>
+        </p:txBody>
+      </p:sp>
     </p:spTree>
   </p:cSld>
   <p:clrMapOvr>
@@ -4221,8 +5029,8 @@
         </p:nvSpPr>
         <p:spPr>
           <a:xfrm>
-            <a:off x="914400" y="1645920"/>
-            <a:ext cx="8229600" cy="914400"/>
+            <a:off x="1371600" y="2286000"/>
+            <a:ext cx="9144000" cy="1645920"/>
           </a:xfrm>
           <a:prstGeom prst="rect">
             <a:avLst/>
@@ -4235,8 +5043,16 @@
           </a:bodyPr>
           <a:lstStyle/>
           <a:p>
-            <a:r>
-              <a:t>Client Testimonial</a:t>
+            <a:pPr>
+              <a:defRPr sz="2200" i="1">
+                <a:solidFill>
+                  <a:srgbClr val="18181B"/>
+                </a:solidFill>
+                <a:latin typeface="Times New Roman"/>
+              </a:defRPr>
+            </a:pPr>
+            <a:r>
+              <a:t>"BrandMorph transformed our enterprise presentation workflow into an automated, brand-governed content supply chain."</a:t>
             </a:r>
           </a:p>
         </p:txBody>
@@ -4249,8 +5065,8 @@
         </p:nvSpPr>
         <p:spPr>
           <a:xfrm>
-            <a:off x="914400" y="2743200"/>
-            <a:ext cx="8229600" cy="1371600"/>
+            <a:off x="1371600" y="4114800"/>
+            <a:ext cx="9144000" cy="731520"/>
           </a:xfrm>
           <a:prstGeom prst="rect">
             <a:avLst/>
@@ -4263,8 +5079,87 @@
           </a:bodyPr>
           <a:lstStyle/>
           <a:p>
-            <a:r>
-              <a:t>"BrandMorph transformed our entire enterprise content supply chain in days."</a:t>
+            <a:pPr>
+              <a:defRPr sz="1400" b="1">
+                <a:solidFill>
+                  <a:srgbClr val="64748B"/>
+                </a:solidFill>
+              </a:defRPr>
+            </a:pPr>
+            <a:r>
+              <a:t>— Chief Technology Officer, Fortune 500 Enterprise</a:t>
+            </a:r>
+          </a:p>
+        </p:txBody>
+      </p:sp>
+      <p:sp>
+        <p:nvSpPr>
+          <p:cNvPr id="4" name="TextBox 3"/>
+          <p:cNvSpPr txBox="1"/>
+          <p:nvPr/>
+        </p:nvSpPr>
+        <p:spPr>
+          <a:xfrm>
+            <a:off x="731520" y="6400800"/>
+            <a:ext cx="4114800" cy="320040"/>
+          </a:xfrm>
+          <a:prstGeom prst="rect">
+            <a:avLst/>
+          </a:prstGeom>
+          <a:noFill/>
+        </p:spPr>
+        <p:txBody>
+          <a:bodyPr wrap="none">
+            <a:spAutoFit/>
+          </a:bodyPr>
+          <a:lstStyle/>
+          <a:p>
+            <a:pPr>
+              <a:defRPr sz="850">
+                <a:solidFill>
+                  <a:srgbClr val="8C96A0"/>
+                </a:solidFill>
+                <a:latin typeface="Calibri"/>
+              </a:defRPr>
+            </a:pPr>
+            <a:r>
+              <a:t>PRESENTATION TITLE</a:t>
+            </a:r>
+          </a:p>
+        </p:txBody>
+      </p:sp>
+      <p:sp>
+        <p:nvSpPr>
+          <p:cNvPr id="5" name="TextBox 4"/>
+          <p:cNvSpPr txBox="1"/>
+          <p:nvPr/>
+        </p:nvSpPr>
+        <p:spPr>
+          <a:xfrm>
+            <a:off x="10972800" y="6400800"/>
+            <a:ext cx="548640" cy="320040"/>
+          </a:xfrm>
+          <a:prstGeom prst="rect">
+            <a:avLst/>
+          </a:prstGeom>
+          <a:noFill/>
+        </p:spPr>
+        <p:txBody>
+          <a:bodyPr wrap="none">
+            <a:spAutoFit/>
+          </a:bodyPr>
+          <a:lstStyle/>
+          <a:p>
+            <a:pPr>
+              <a:defRPr sz="850">
+                <a:solidFill>
+                  <a:srgbClr val="8C96A0"/>
+                </a:solidFill>
+                <a:latin typeface="Calibri"/>
+              </a:defRPr>
+            </a:pPr>
+            <a:r>
+              <a:t>6</a:t>
             </a:r>
           </a:p>
         </p:txBody>
@@ -4295,7 +5190,7 @@
         </p:nvSpPr>
         <p:spPr>
           <a:xfrm>
-            <a:off x="914400" y="457200"/>
+            <a:off x="731520" y="548640"/>
             <a:ext cx="7315200" cy="731520"/>
           </a:xfrm>
           <a:prstGeom prst="rect">
@@ -4309,6 +5204,9 @@
           </a:bodyPr>
           <a:lstStyle/>
           <a:p>
+            <a:pPr>
+              <a:defRPr sz="2800"/>
+            </a:pPr>
             <a:r>
               <a:t>Executive Leadership Team</a:t>
             </a:r>
@@ -4331,10 +5229,10 @@
         </p:blipFill>
         <p:spPr>
           <a:xfrm>
-            <a:off x="777240" y="1463040"/>
-            <a:ext cx="2286000" cy="2286000"/>
-          </a:xfrm>
-          <a:prstGeom prst="rect">
+            <a:off x="731520" y="1645920"/>
+            <a:ext cx="2194560" cy="2194560"/>
+          </a:xfrm>
+          <a:prstGeom prst="ellipse">
             <a:avLst/>
           </a:prstGeom>
         </p:spPr>
@@ -4347,8 +5245,8 @@
         </p:nvSpPr>
         <p:spPr>
           <a:xfrm>
-            <a:off x="777240" y="3931920"/>
-            <a:ext cx="2286000" cy="320040"/>
+            <a:off x="731520" y="4023360"/>
+            <a:ext cx="2194560" cy="365760"/>
           </a:xfrm>
           <a:prstGeom prst="rect">
             <a:avLst/>
@@ -4361,6 +5259,9 @@
           </a:bodyPr>
           <a:lstStyle/>
           <a:p>
+            <a:pPr>
+              <a:defRPr sz="1300" b="1"/>
+            </a:pPr>
             <a:r>
               <a:t>Alex Rivera</a:t>
             </a:r>
@@ -4375,8 +5276,8 @@
         </p:nvSpPr>
         <p:spPr>
           <a:xfrm>
-            <a:off x="777240" y="4297680"/>
-            <a:ext cx="2286000" cy="320040"/>
+            <a:off x="731520" y="4389120"/>
+            <a:ext cx="2194560" cy="365760"/>
           </a:xfrm>
           <a:prstGeom prst="rect">
             <a:avLst/>
@@ -4389,6 +5290,13 @@
           </a:bodyPr>
           <a:lstStyle/>
           <a:p>
+            <a:pPr>
+              <a:defRPr sz="1000">
+                <a:solidFill>
+                  <a:srgbClr val="64748B"/>
+                </a:solidFill>
+              </a:defRPr>
+            </a:pPr>
             <a:r>
               <a:t>Chief Executive Officer</a:t>
             </a:r>
@@ -4404,17 +5312,17 @@
           <p:nvPr/>
         </p:nvPicPr>
         <p:blipFill>
-          <a:blip r:embed="rId2"/>
+          <a:blip r:embed="rId3"/>
           <a:stretch>
             <a:fillRect/>
           </a:stretch>
         </p:blipFill>
         <p:spPr>
           <a:xfrm>
-            <a:off x="3611880" y="1463040"/>
-            <a:ext cx="2286000" cy="2286000"/>
-          </a:xfrm>
-          <a:prstGeom prst="rect">
+            <a:off x="3429000" y="1645920"/>
+            <a:ext cx="2194560" cy="2194560"/>
+          </a:xfrm>
+          <a:prstGeom prst="ellipse">
             <a:avLst/>
           </a:prstGeom>
         </p:spPr>
@@ -4427,8 +5335,8 @@
         </p:nvSpPr>
         <p:spPr>
           <a:xfrm>
-            <a:off x="3611880" y="3931920"/>
-            <a:ext cx="2286000" cy="320040"/>
+            <a:off x="3429000" y="4023360"/>
+            <a:ext cx="2194560" cy="365760"/>
           </a:xfrm>
           <a:prstGeom prst="rect">
             <a:avLst/>
@@ -4441,6 +5349,9 @@
           </a:bodyPr>
           <a:lstStyle/>
           <a:p>
+            <a:pPr>
+              <a:defRPr sz="1300" b="1"/>
+            </a:pPr>
             <a:r>
               <a:t>Sarah Chen</a:t>
             </a:r>
@@ -4455,8 +5366,8 @@
         </p:nvSpPr>
         <p:spPr>
           <a:xfrm>
-            <a:off x="3611880" y="4297680"/>
-            <a:ext cx="2286000" cy="320040"/>
+            <a:off x="3429000" y="4389120"/>
+            <a:ext cx="2194560" cy="365760"/>
           </a:xfrm>
           <a:prstGeom prst="rect">
             <a:avLst/>
@@ -4469,6 +5380,13 @@
           </a:bodyPr>
           <a:lstStyle/>
           <a:p>
+            <a:pPr>
+              <a:defRPr sz="1000">
+                <a:solidFill>
+                  <a:srgbClr val="64748B"/>
+                </a:solidFill>
+              </a:defRPr>
+            </a:pPr>
             <a:r>
               <a:t>VP Engineering</a:t>
             </a:r>
@@ -4484,17 +5402,17 @@
           <p:nvPr/>
         </p:nvPicPr>
         <p:blipFill>
-          <a:blip r:embed="rId2"/>
+          <a:blip r:embed="rId4"/>
           <a:stretch>
             <a:fillRect/>
           </a:stretch>
         </p:blipFill>
         <p:spPr>
           <a:xfrm>
-            <a:off x="6446520" y="1463040"/>
-            <a:ext cx="2286000" cy="2286000"/>
-          </a:xfrm>
-          <a:prstGeom prst="rect">
+            <a:off x="6126480" y="1645920"/>
+            <a:ext cx="2194560" cy="2194560"/>
+          </a:xfrm>
+          <a:prstGeom prst="ellipse">
             <a:avLst/>
           </a:prstGeom>
         </p:spPr>
@@ -4507,8 +5425,8 @@
         </p:nvSpPr>
         <p:spPr>
           <a:xfrm>
-            <a:off x="6446520" y="3931920"/>
-            <a:ext cx="2286000" cy="320040"/>
+            <a:off x="6126480" y="4023360"/>
+            <a:ext cx="2194560" cy="365760"/>
           </a:xfrm>
           <a:prstGeom prst="rect">
             <a:avLst/>
@@ -4521,6 +5439,9 @@
           </a:bodyPr>
           <a:lstStyle/>
           <a:p>
+            <a:pPr>
+              <a:defRPr sz="1300" b="1"/>
+            </a:pPr>
             <a:r>
               <a:t>Marcus Vance</a:t>
             </a:r>
@@ -4535,8 +5456,8 @@
         </p:nvSpPr>
         <p:spPr>
           <a:xfrm>
-            <a:off x="6446520" y="4297680"/>
-            <a:ext cx="2286000" cy="320040"/>
+            <a:off x="6126480" y="4389120"/>
+            <a:ext cx="2194560" cy="365760"/>
           </a:xfrm>
           <a:prstGeom prst="rect">
             <a:avLst/>
@@ -4549,6 +5470,13 @@
           </a:bodyPr>
           <a:lstStyle/>
           <a:p>
+            <a:pPr>
+              <a:defRPr sz="1000">
+                <a:solidFill>
+                  <a:srgbClr val="64748B"/>
+                </a:solidFill>
+              </a:defRPr>
+            </a:pPr>
             <a:r>
               <a:t>Chief Product Officer</a:t>
             </a:r>
@@ -4564,17 +5492,17 @@
           <p:nvPr/>
         </p:nvPicPr>
         <p:blipFill>
-          <a:blip r:embed="rId2"/>
+          <a:blip r:embed="rId5"/>
           <a:stretch>
             <a:fillRect/>
           </a:stretch>
         </p:blipFill>
         <p:spPr>
           <a:xfrm>
-            <a:off x="9281160" y="1463040"/>
-            <a:ext cx="2286000" cy="2286000"/>
-          </a:xfrm>
-          <a:prstGeom prst="rect">
+            <a:off x="8823960" y="1645920"/>
+            <a:ext cx="2194560" cy="2194560"/>
+          </a:xfrm>
+          <a:prstGeom prst="ellipse">
             <a:avLst/>
           </a:prstGeom>
         </p:spPr>
@@ -4587,8 +5515,8 @@
         </p:nvSpPr>
         <p:spPr>
           <a:xfrm>
-            <a:off x="9281160" y="3931920"/>
-            <a:ext cx="2286000" cy="320040"/>
+            <a:off x="8823960" y="4023360"/>
+            <a:ext cx="2194560" cy="365760"/>
           </a:xfrm>
           <a:prstGeom prst="rect">
             <a:avLst/>
@@ -4601,6 +5529,9 @@
           </a:bodyPr>
           <a:lstStyle/>
           <a:p>
+            <a:pPr>
+              <a:defRPr sz="1300" b="1"/>
+            </a:pPr>
             <a:r>
               <a:t>Elena Rostova</a:t>
             </a:r>
@@ -4615,8 +5546,8 @@
         </p:nvSpPr>
         <p:spPr>
           <a:xfrm>
-            <a:off x="9281160" y="4297680"/>
-            <a:ext cx="2286000" cy="320040"/>
+            <a:off x="8823960" y="4389120"/>
+            <a:ext cx="2194560" cy="365760"/>
           </a:xfrm>
           <a:prstGeom prst="rect">
             <a:avLst/>
@@ -4629,8 +5560,87 @@
           </a:bodyPr>
           <a:lstStyle/>
           <a:p>
+            <a:pPr>
+              <a:defRPr sz="1000">
+                <a:solidFill>
+                  <a:srgbClr val="64748B"/>
+                </a:solidFill>
+              </a:defRPr>
+            </a:pPr>
             <a:r>
               <a:t>Head of Design</a:t>
+            </a:r>
+          </a:p>
+        </p:txBody>
+      </p:sp>
+      <p:sp>
+        <p:nvSpPr>
+          <p:cNvPr id="15" name="TextBox 14"/>
+          <p:cNvSpPr txBox="1"/>
+          <p:nvPr/>
+        </p:nvSpPr>
+        <p:spPr>
+          <a:xfrm>
+            <a:off x="731520" y="6400800"/>
+            <a:ext cx="4114800" cy="320040"/>
+          </a:xfrm>
+          <a:prstGeom prst="rect">
+            <a:avLst/>
+          </a:prstGeom>
+          <a:noFill/>
+        </p:spPr>
+        <p:txBody>
+          <a:bodyPr wrap="none">
+            <a:spAutoFit/>
+          </a:bodyPr>
+          <a:lstStyle/>
+          <a:p>
+            <a:pPr>
+              <a:defRPr sz="850">
+                <a:solidFill>
+                  <a:srgbClr val="8C96A0"/>
+                </a:solidFill>
+                <a:latin typeface="Calibri"/>
+              </a:defRPr>
+            </a:pPr>
+            <a:r>
+              <a:t>PRESENTATION TITLE</a:t>
+            </a:r>
+          </a:p>
+        </p:txBody>
+      </p:sp>
+      <p:sp>
+        <p:nvSpPr>
+          <p:cNvPr id="16" name="TextBox 15"/>
+          <p:cNvSpPr txBox="1"/>
+          <p:nvPr/>
+        </p:nvSpPr>
+        <p:spPr>
+          <a:xfrm>
+            <a:off x="10972800" y="6400800"/>
+            <a:ext cx="548640" cy="320040"/>
+          </a:xfrm>
+          <a:prstGeom prst="rect">
+            <a:avLst/>
+          </a:prstGeom>
+          <a:noFill/>
+        </p:spPr>
+        <p:txBody>
+          <a:bodyPr wrap="none">
+            <a:spAutoFit/>
+          </a:bodyPr>
+          <a:lstStyle/>
+          <a:p>
+            <a:pPr>
+              <a:defRPr sz="850">
+                <a:solidFill>
+                  <a:srgbClr val="8C96A0"/>
+                </a:solidFill>
+                <a:latin typeface="Calibri"/>
+              </a:defRPr>
+            </a:pPr>
+            <a:r>
+              <a:t>7</a:t>
             </a:r>
           </a:p>
         </p:txBody>
@@ -4661,7 +5671,7 @@
         </p:nvSpPr>
         <p:spPr>
           <a:xfrm>
-            <a:off x="914400" y="457200"/>
+            <a:off x="731520" y="548640"/>
             <a:ext cx="7315200" cy="731520"/>
           </a:xfrm>
           <a:prstGeom prst="rect">
@@ -4675,6 +5685,9 @@
           </a:bodyPr>
           <a:lstStyle/>
           <a:p>
+            <a:pPr>
+              <a:defRPr sz="2800"/>
+            </a:pPr>
             <a:r>
               <a:t>Product Delivery Timeline</a:t>
             </a:r>
@@ -4689,15 +5702,20 @@
         </p:nvSpPr>
         <p:spPr>
           <a:xfrm>
-            <a:off x="914400" y="2286000"/>
-            <a:ext cx="2194560" cy="2560320"/>
+            <a:off x="731520" y="1828800"/>
+            <a:ext cx="2468880" cy="3840480"/>
           </a:xfrm>
           <a:prstGeom prst="rect">
             <a:avLst/>
           </a:prstGeom>
           <a:solidFill>
-            <a:srgbClr val="081632"/>
+            <a:srgbClr val="F1F5F9"/>
           </a:solidFill>
+          <a:ln>
+            <a:solidFill>
+              <a:srgbClr val="E2E8F0"/>
+            </a:solidFill>
+          </a:ln>
         </p:spPr>
         <p:style>
           <a:lnRef idx="1">
@@ -4718,10 +5736,26 @@
           <a:lstStyle/>
           <a:p>
             <a:pPr algn="ctr">
-              <a:defRPr sz="1300"/>
+              <a:defRPr sz="1300" b="1">
+                <a:solidFill>
+                  <a:srgbClr val="18181B"/>
+                </a:solidFill>
+              </a:defRPr>
             </a:pPr>
             <a:r>
               <a:t>Q1: Discovery</a:t>
+            </a:r>
+          </a:p>
+          <a:p>
+            <a:pPr>
+              <a:defRPr sz="1000">
+                <a:solidFill>
+                  <a:srgbClr val="475569"/>
+                </a:solidFill>
+              </a:defRPr>
+            </a:pPr>
+            <a:r>
+              <a:t>Decompile existing slide library, extract AST graph, normalize tokens.</a:t>
             </a:r>
           </a:p>
         </p:txBody>
@@ -4734,15 +5768,20 @@
         </p:nvSpPr>
         <p:spPr>
           <a:xfrm>
-            <a:off x="3474720" y="2286000"/>
-            <a:ext cx="2194560" cy="2560320"/>
+            <a:off x="3429000" y="1828800"/>
+            <a:ext cx="2468880" cy="3840480"/>
           </a:xfrm>
           <a:prstGeom prst="rect">
             <a:avLst/>
           </a:prstGeom>
           <a:solidFill>
-            <a:srgbClr val="00FFFF"/>
+            <a:srgbClr val="FEF3C7"/>
           </a:solidFill>
+          <a:ln>
+            <a:solidFill>
+              <a:srgbClr val="E2E8F0"/>
+            </a:solidFill>
+          </a:ln>
         </p:spPr>
         <p:style>
           <a:lnRef idx="1">
@@ -4763,10 +5802,26 @@
           <a:lstStyle/>
           <a:p>
             <a:pPr algn="ctr">
-              <a:defRPr sz="1300"/>
+              <a:defRPr sz="1300" b="1">
+                <a:solidFill>
+                  <a:srgbClr val="18181B"/>
+                </a:solidFill>
+              </a:defRPr>
             </a:pPr>
             <a:r>
               <a:t>Q2: Architecture</a:t>
+            </a:r>
+          </a:p>
+          <a:p>
+            <a:pPr>
+              <a:defRPr sz="1000">
+                <a:solidFill>
+                  <a:srgbClr val="475569"/>
+                </a:solidFill>
+              </a:defRPr>
+            </a:pPr>
+            <a:r>
+              <a:t>Deploy SlideGNN neural model and WCAG 2.1 color contrast solver.</a:t>
             </a:r>
           </a:p>
         </p:txBody>
@@ -4779,15 +5834,20 @@
         </p:nvSpPr>
         <p:spPr>
           <a:xfrm>
-            <a:off x="6035040" y="2286000"/>
-            <a:ext cx="2194560" cy="2560320"/>
+            <a:off x="6126480" y="1828800"/>
+            <a:ext cx="2468880" cy="3840480"/>
           </a:xfrm>
           <a:prstGeom prst="rect">
             <a:avLst/>
           </a:prstGeom>
           <a:solidFill>
-            <a:srgbClr val="081632"/>
+            <a:srgbClr val="F1F5F9"/>
           </a:solidFill>
+          <a:ln>
+            <a:solidFill>
+              <a:srgbClr val="E2E8F0"/>
+            </a:solidFill>
+          </a:ln>
         </p:spPr>
         <p:style>
           <a:lnRef idx="1">
@@ -4808,10 +5868,26 @@
           <a:lstStyle/>
           <a:p>
             <a:pPr algn="ctr">
-              <a:defRPr sz="1300"/>
+              <a:defRPr sz="1300" b="1">
+                <a:solidFill>
+                  <a:srgbClr val="18181B"/>
+                </a:solidFill>
+              </a:defRPr>
             </a:pPr>
             <a:r>
               <a:t>Q3: Deployment</a:t>
+            </a:r>
+          </a:p>
+          <a:p>
+            <a:pPr>
+              <a:defRPr sz="1000">
+                <a:solidFill>
+                  <a:srgbClr val="475569"/>
+                </a:solidFill>
+              </a:defRPr>
+            </a:pPr>
+            <a:r>
+              <a:t>Ship high-craft React &amp; Tauri client with before/after visual inspection.</a:t>
             </a:r>
           </a:p>
         </p:txBody>
@@ -4824,15 +5900,20 @@
         </p:nvSpPr>
         <p:spPr>
           <a:xfrm>
-            <a:off x="8595359" y="2286000"/>
-            <a:ext cx="2194560" cy="2560320"/>
+            <a:off x="8823960" y="1828800"/>
+            <a:ext cx="2468880" cy="3840480"/>
           </a:xfrm>
           <a:prstGeom prst="rect">
             <a:avLst/>
           </a:prstGeom>
           <a:solidFill>
-            <a:srgbClr val="081632"/>
+            <a:srgbClr val="F1F5F9"/>
           </a:solidFill>
+          <a:ln>
+            <a:solidFill>
+              <a:srgbClr val="E2E8F0"/>
+            </a:solidFill>
+          </a:ln>
         </p:spPr>
         <p:style>
           <a:lnRef idx="1">
@@ -4853,10 +5934,98 @@
           <a:lstStyle/>
           <a:p>
             <a:pPr algn="ctr">
-              <a:defRPr sz="1300"/>
+              <a:defRPr sz="1300" b="1">
+                <a:solidFill>
+                  <a:srgbClr val="18181B"/>
+                </a:solidFill>
+              </a:defRPr>
             </a:pPr>
             <a:r>
               <a:t>Q4: Scale</a:t>
+            </a:r>
+          </a:p>
+          <a:p>
+            <a:pPr>
+              <a:defRPr sz="1000">
+                <a:solidFill>
+                  <a:srgbClr val="475569"/>
+                </a:solidFill>
+              </a:defRPr>
+            </a:pPr>
+            <a:r>
+              <a:t>Full enterprise automated deck migration across Fortune 500 tenants.</a:t>
+            </a:r>
+          </a:p>
+        </p:txBody>
+      </p:sp>
+      <p:sp>
+        <p:nvSpPr>
+          <p:cNvPr id="7" name="TextBox 6"/>
+          <p:cNvSpPr txBox="1"/>
+          <p:nvPr/>
+        </p:nvSpPr>
+        <p:spPr>
+          <a:xfrm>
+            <a:off x="731520" y="6400800"/>
+            <a:ext cx="4114800" cy="320040"/>
+          </a:xfrm>
+          <a:prstGeom prst="rect">
+            <a:avLst/>
+          </a:prstGeom>
+          <a:noFill/>
+        </p:spPr>
+        <p:txBody>
+          <a:bodyPr wrap="none">
+            <a:spAutoFit/>
+          </a:bodyPr>
+          <a:lstStyle/>
+          <a:p>
+            <a:pPr>
+              <a:defRPr sz="850">
+                <a:solidFill>
+                  <a:srgbClr val="8C96A0"/>
+                </a:solidFill>
+                <a:latin typeface="Calibri"/>
+              </a:defRPr>
+            </a:pPr>
+            <a:r>
+              <a:t>PRESENTATION TITLE</a:t>
+            </a:r>
+          </a:p>
+        </p:txBody>
+      </p:sp>
+      <p:sp>
+        <p:nvSpPr>
+          <p:cNvPr id="8" name="TextBox 7"/>
+          <p:cNvSpPr txBox="1"/>
+          <p:nvPr/>
+        </p:nvSpPr>
+        <p:spPr>
+          <a:xfrm>
+            <a:off x="10972800" y="6400800"/>
+            <a:ext cx="548640" cy="320040"/>
+          </a:xfrm>
+          <a:prstGeom prst="rect">
+            <a:avLst/>
+          </a:prstGeom>
+          <a:noFill/>
+        </p:spPr>
+        <p:txBody>
+          <a:bodyPr wrap="none">
+            <a:spAutoFit/>
+          </a:bodyPr>
+          <a:lstStyle/>
+          <a:p>
+            <a:pPr>
+              <a:defRPr sz="850">
+                <a:solidFill>
+                  <a:srgbClr val="8C96A0"/>
+                </a:solidFill>
+                <a:latin typeface="Calibri"/>
+              </a:defRPr>
+            </a:pPr>
+            <a:r>
+              <a:t>8</a:t>
             </a:r>
           </a:p>
         </p:txBody>
@@ -4887,7 +6056,7 @@
         </p:nvSpPr>
         <p:spPr>
           <a:xfrm>
-            <a:off x="731520" y="457200"/>
+            <a:off x="731520" y="548640"/>
             <a:ext cx="7315200" cy="731520"/>
           </a:xfrm>
           <a:prstGeom prst="rect">
@@ -4901,6 +6070,9 @@
           </a:bodyPr>
           <a:lstStyle/>
           <a:p>
+            <a:pPr>
+              <a:defRPr sz="2800"/>
+            </a:pPr>
             <a:r>
               <a:t>Key Transformation Pillars</a:t>
             </a:r>
@@ -4916,7 +6088,7 @@
         <p:spPr>
           <a:xfrm>
             <a:off x="731520" y="1828800"/>
-            <a:ext cx="3291840" cy="3474720"/>
+            <a:ext cx="3291840" cy="3840480"/>
           </a:xfrm>
           <a:prstGeom prst="rect">
             <a:avLst/>
@@ -4930,15 +6102,18 @@
           <a:lstStyle/>
           <a:p>
             <a:pPr>
-              <a:defRPr b="1"/>
-            </a:pPr>
-            <a:r>
-              <a:t>Pillar 01</a:t>
-            </a:r>
-          </a:p>
-          <a:p>
-            <a:r>
-              <a:t>High-velocity pipeline automation enforcing compliance and typography.</a:t>
+              <a:defRPr sz="1400" b="1"/>
+            </a:pPr>
+            <a:r>
+              <a:t>Automated Compliance</a:t>
+            </a:r>
+          </a:p>
+          <a:p>
+            <a:pPr>
+              <a:defRPr sz="1100"/>
+            </a:pPr>
+            <a:r>
+              <a:t>Continuous auditing of brand guidelines, font normalization, and OpenXML coordinate hygiene.</a:t>
             </a:r>
           </a:p>
         </p:txBody>
@@ -4951,8 +6126,8 @@
         </p:nvSpPr>
         <p:spPr>
           <a:xfrm>
-            <a:off x="4389120" y="1828800"/>
-            <a:ext cx="3291840" cy="3474720"/>
+            <a:off x="4343400" y="1828800"/>
+            <a:ext cx="3291840" cy="3840480"/>
           </a:xfrm>
           <a:prstGeom prst="rect">
             <a:avLst/>
@@ -4966,15 +6141,18 @@
           <a:lstStyle/>
           <a:p>
             <a:pPr>
-              <a:defRPr b="1"/>
-            </a:pPr>
-            <a:r>
-              <a:t>Pillar 02</a:t>
-            </a:r>
-          </a:p>
-          <a:p>
-            <a:r>
-              <a:t>High-velocity pipeline automation enforcing compliance and typography.</a:t>
+              <a:defRPr sz="1400" b="1"/>
+            </a:pPr>
+            <a:r>
+              <a:t>Deterministic Layout</a:t>
+            </a:r>
+          </a:p>
+          <a:p>
+            <a:pPr>
+              <a:defRPr sz="1100"/>
+            </a:pPr>
+            <a:r>
+              <a:t>Top-left snapping, clean whitespace preservation, and zero destructive coordinate overwrites.</a:t>
             </a:r>
           </a:p>
         </p:txBody>
@@ -4987,8 +6165,8 @@
         </p:nvSpPr>
         <p:spPr>
           <a:xfrm>
-            <a:off x="8046720" y="1828800"/>
-            <a:ext cx="3291840" cy="3474720"/>
+            <a:off x="7955280" y="1828800"/>
+            <a:ext cx="3291840" cy="3840480"/>
           </a:xfrm>
           <a:prstGeom prst="rect">
             <a:avLst/>
@@ -5002,15 +6180,90 @@
           <a:lstStyle/>
           <a:p>
             <a:pPr>
-              <a:defRPr b="1"/>
-            </a:pPr>
-            <a:r>
-              <a:t>Pillar 03</a:t>
-            </a:r>
-          </a:p>
-          <a:p>
-            <a:r>
-              <a:t>High-velocity pipeline automation enforcing compliance and typography.</a:t>
+              <a:defRPr sz="1400" b="1"/>
+            </a:pPr>
+            <a:r>
+              <a:t>Universal Export</a:t>
+            </a:r>
+          </a:p>
+          <a:p>
+            <a:pPr>
+              <a:defRPr sz="1100"/>
+            </a:pPr>
+            <a:r>
+              <a:t>One-click PPTX builder producing pristine binary presentations ready for executive boardroom display.</a:t>
+            </a:r>
+          </a:p>
+        </p:txBody>
+      </p:sp>
+      <p:sp>
+        <p:nvSpPr>
+          <p:cNvPr id="6" name="TextBox 5"/>
+          <p:cNvSpPr txBox="1"/>
+          <p:nvPr/>
+        </p:nvSpPr>
+        <p:spPr>
+          <a:xfrm>
+            <a:off x="731520" y="6400800"/>
+            <a:ext cx="4114800" cy="320040"/>
+          </a:xfrm>
+          <a:prstGeom prst="rect">
+            <a:avLst/>
+          </a:prstGeom>
+          <a:noFill/>
+        </p:spPr>
+        <p:txBody>
+          <a:bodyPr wrap="none">
+            <a:spAutoFit/>
+          </a:bodyPr>
+          <a:lstStyle/>
+          <a:p>
+            <a:pPr>
+              <a:defRPr sz="850">
+                <a:solidFill>
+                  <a:srgbClr val="8C96A0"/>
+                </a:solidFill>
+                <a:latin typeface="Calibri"/>
+              </a:defRPr>
+            </a:pPr>
+            <a:r>
+              <a:t>PRESENTATION TITLE</a:t>
+            </a:r>
+          </a:p>
+        </p:txBody>
+      </p:sp>
+      <p:sp>
+        <p:nvSpPr>
+          <p:cNvPr id="7" name="TextBox 6"/>
+          <p:cNvSpPr txBox="1"/>
+          <p:nvPr/>
+        </p:nvSpPr>
+        <p:spPr>
+          <a:xfrm>
+            <a:off x="10972800" y="6400800"/>
+            <a:ext cx="548640" cy="320040"/>
+          </a:xfrm>
+          <a:prstGeom prst="rect">
+            <a:avLst/>
+          </a:prstGeom>
+          <a:noFill/>
+        </p:spPr>
+        <p:txBody>
+          <a:bodyPr wrap="none">
+            <a:spAutoFit/>
+          </a:bodyPr>
+          <a:lstStyle/>
+          <a:p>
+            <a:pPr>
+              <a:defRPr sz="850">
+                <a:solidFill>
+                  <a:srgbClr val="8C96A0"/>
+                </a:solidFill>
+                <a:latin typeface="Calibri"/>
+              </a:defRPr>
+            </a:pPr>
+            <a:r>
+              <a:t>9</a:t>
             </a:r>
           </a:p>
         </p:txBody>

</xml_diff>